<commit_message>
feat: add async video ingestion pipeline with Celery, Redis, and MongoDB status tracking
</commit_message>
<xml_diff>
--- a/lecturelensai.pptx
+++ b/lecturelensai.pptx
@@ -8068,13 +8068,13 @@
       <dgm:prSet presAssocID="{9D0F8735-C624-4548-80E5-0B9D5FE8F889}" presName="imgShp" presStyleLbl="fgImgPlace1" presStyleIdx="0" presStyleCnt="6" custLinFactNeighborX="-20186" custLinFactNeighborY="-19"/>
       <dgm:spPr>
         <a:blipFill dpi="0" rotWithShape="1">
-          <a:blip xmlns:r="http://schemas.openxmlformats.org/officeDocument/2006/relationships" r:embed="rId1">
+          <a:blip xmlns:r="http://schemas.openxmlformats.org/officeDocument/2006/relationships">
             <a:extLst>
               <a:ext uri="{28A0092B-C50C-407E-A947-70E740481C1C}">
                 <a14:useLocalDpi xmlns:a14="http://schemas.microsoft.com/office/drawing/2010/main" val="0"/>
               </a:ext>
               <a:ext uri="{96DAC541-7B7A-43D3-8B79-37D633B846F1}">
-                <asvg:svgBlip xmlns:asvg="http://schemas.microsoft.com/office/drawing/2016/SVG/main" r:embed="rId2"/>
+                <asvg:svgBlip xmlns:asvg="http://schemas.microsoft.com/office/drawing/2016/SVG/main" r:embed="rId1"/>
               </a:ext>
             </a:extLst>
           </a:blip>
@@ -8105,7 +8105,7 @@
       <dgm:prSet presAssocID="{BC196088-2325-4645-B054-0517746EED0A}" presName="imgShp" presStyleLbl="fgImgPlace1" presStyleIdx="1" presStyleCnt="6" custLinFactNeighborX="-12288" custLinFactNeighborY="2633"/>
       <dgm:spPr>
         <a:blipFill dpi="0" rotWithShape="1">
-          <a:blip xmlns:r="http://schemas.openxmlformats.org/officeDocument/2006/relationships" r:embed="rId3">
+          <a:blip xmlns:r="http://schemas.openxmlformats.org/officeDocument/2006/relationships" r:embed="rId2">
             <a:extLst>
               <a:ext uri="{28A0092B-C50C-407E-A947-70E740481C1C}">
                 <a14:useLocalDpi xmlns:a14="http://schemas.microsoft.com/office/drawing/2010/main" val="0"/>
@@ -8139,7 +8139,7 @@
       <dgm:prSet presAssocID="{91BC81F4-0447-4AEA-B2DD-9868BA623423}" presName="imgShp" presStyleLbl="fgImgPlace1" presStyleIdx="2" presStyleCnt="6" custScaleX="151706" custScaleY="118818" custLinFactNeighborX="-35373" custLinFactNeighborY="-8106"/>
       <dgm:spPr>
         <a:blipFill dpi="0" rotWithShape="1">
-          <a:blip xmlns:r="http://schemas.openxmlformats.org/officeDocument/2006/relationships" r:embed="rId4">
+          <a:blip xmlns:r="http://schemas.openxmlformats.org/officeDocument/2006/relationships" r:embed="rId3">
             <a:extLst>
               <a:ext uri="{28A0092B-C50C-407E-A947-70E740481C1C}">
                 <a14:useLocalDpi xmlns:a14="http://schemas.microsoft.com/office/drawing/2010/main" val="0"/>
@@ -8173,7 +8173,7 @@
       <dgm:prSet presAssocID="{BC0CAC2E-86DC-4928-A6C0-AF7269D3D210}" presName="imgShp" presStyleLbl="fgImgPlace1" presStyleIdx="3" presStyleCnt="6" custScaleX="125395" custScaleY="114630" custLinFactNeighborX="-13129" custLinFactNeighborY="-1876"/>
       <dgm:spPr>
         <a:blipFill dpi="0" rotWithShape="1">
-          <a:blip xmlns:r="http://schemas.openxmlformats.org/officeDocument/2006/relationships" r:embed="rId5">
+          <a:blip xmlns:r="http://schemas.openxmlformats.org/officeDocument/2006/relationships" r:embed="rId4">
             <a:extLst>
               <a:ext uri="{28A0092B-C50C-407E-A947-70E740481C1C}">
                 <a14:useLocalDpi xmlns:a14="http://schemas.microsoft.com/office/drawing/2010/main" val="0"/>
@@ -8207,7 +8207,7 @@
       <dgm:prSet presAssocID="{A6E4ADAE-906E-43D9-A832-5FA80F949027}" presName="imgShp" presStyleLbl="fgImgPlace1" presStyleIdx="4" presStyleCnt="6" custScaleX="102761" custScaleY="118545" custLinFactNeighborX="-9783"/>
       <dgm:spPr>
         <a:blipFill dpi="0" rotWithShape="1">
-          <a:blip xmlns:r="http://schemas.openxmlformats.org/officeDocument/2006/relationships" r:embed="rId6">
+          <a:blip xmlns:r="http://schemas.openxmlformats.org/officeDocument/2006/relationships" r:embed="rId5">
             <a:extLst>
               <a:ext uri="{28A0092B-C50C-407E-A947-70E740481C1C}">
                 <a14:useLocalDpi xmlns:a14="http://schemas.microsoft.com/office/drawing/2010/main" val="0"/>
@@ -8241,7 +8241,7 @@
       <dgm:prSet presAssocID="{754FD87A-6662-4E59-A2BA-A9D90F274E36}" presName="imgShp" presStyleLbl="fgImgPlace1" presStyleIdx="5" presStyleCnt="6"/>
       <dgm:spPr>
         <a:blipFill dpi="0" rotWithShape="1">
-          <a:blip xmlns:r="http://schemas.openxmlformats.org/officeDocument/2006/relationships" r:embed="rId7">
+          <a:blip xmlns:r="http://schemas.openxmlformats.org/officeDocument/2006/relationships" r:embed="rId6">
             <a:extLst>
               <a:ext uri="{28A0092B-C50C-407E-A947-70E740481C1C}">
                 <a14:useLocalDpi xmlns:a14="http://schemas.microsoft.com/office/drawing/2010/main" val="0"/>
@@ -11606,13 +11606,13 @@
           <a:avLst/>
         </a:prstGeom>
         <a:blipFill dpi="0" rotWithShape="1">
-          <a:blip xmlns:r="http://schemas.openxmlformats.org/officeDocument/2006/relationships" r:embed="rId1">
+          <a:blip xmlns:r="http://schemas.openxmlformats.org/officeDocument/2006/relationships">
             <a:extLst>
               <a:ext uri="{28A0092B-C50C-407E-A947-70E740481C1C}">
                 <a14:useLocalDpi xmlns:a14="http://schemas.microsoft.com/office/drawing/2010/main" val="0"/>
               </a:ext>
               <a:ext uri="{96DAC541-7B7A-43D3-8B79-37D633B846F1}">
-                <asvg:svgBlip xmlns:asvg="http://schemas.microsoft.com/office/drawing/2016/SVG/main" r:embed="rId2"/>
+                <asvg:svgBlip xmlns:asvg="http://schemas.microsoft.com/office/drawing/2016/SVG/main" r:embed="rId1"/>
               </a:ext>
             </a:extLst>
           </a:blip>
@@ -11748,7 +11748,7 @@
           <a:avLst/>
         </a:prstGeom>
         <a:blipFill dpi="0" rotWithShape="1">
-          <a:blip xmlns:r="http://schemas.openxmlformats.org/officeDocument/2006/relationships" r:embed="rId3">
+          <a:blip xmlns:r="http://schemas.openxmlformats.org/officeDocument/2006/relationships" r:embed="rId2">
             <a:extLst>
               <a:ext uri="{28A0092B-C50C-407E-A947-70E740481C1C}">
                 <a14:useLocalDpi xmlns:a14="http://schemas.microsoft.com/office/drawing/2010/main" val="0"/>
@@ -11887,7 +11887,7 @@
           <a:avLst/>
         </a:prstGeom>
         <a:blipFill dpi="0" rotWithShape="1">
-          <a:blip xmlns:r="http://schemas.openxmlformats.org/officeDocument/2006/relationships" r:embed="rId4">
+          <a:blip xmlns:r="http://schemas.openxmlformats.org/officeDocument/2006/relationships" r:embed="rId3">
             <a:extLst>
               <a:ext uri="{28A0092B-C50C-407E-A947-70E740481C1C}">
                 <a14:useLocalDpi xmlns:a14="http://schemas.microsoft.com/office/drawing/2010/main" val="0"/>
@@ -12026,7 +12026,7 @@
           <a:avLst/>
         </a:prstGeom>
         <a:blipFill dpi="0" rotWithShape="1">
-          <a:blip xmlns:r="http://schemas.openxmlformats.org/officeDocument/2006/relationships" r:embed="rId5">
+          <a:blip xmlns:r="http://schemas.openxmlformats.org/officeDocument/2006/relationships" r:embed="rId4">
             <a:extLst>
               <a:ext uri="{28A0092B-C50C-407E-A947-70E740481C1C}">
                 <a14:useLocalDpi xmlns:a14="http://schemas.microsoft.com/office/drawing/2010/main" val="0"/>
@@ -12190,7 +12190,7 @@
           <a:avLst/>
         </a:prstGeom>
         <a:blipFill dpi="0" rotWithShape="1">
-          <a:blip xmlns:r="http://schemas.openxmlformats.org/officeDocument/2006/relationships" r:embed="rId6">
+          <a:blip xmlns:r="http://schemas.openxmlformats.org/officeDocument/2006/relationships" r:embed="rId5">
             <a:extLst>
               <a:ext uri="{28A0092B-C50C-407E-A947-70E740481C1C}">
                 <a14:useLocalDpi xmlns:a14="http://schemas.microsoft.com/office/drawing/2010/main" val="0"/>
@@ -12329,7 +12329,7 @@
           <a:avLst/>
         </a:prstGeom>
         <a:blipFill dpi="0" rotWithShape="1">
-          <a:blip xmlns:r="http://schemas.openxmlformats.org/officeDocument/2006/relationships" r:embed="rId7">
+          <a:blip xmlns:r="http://schemas.openxmlformats.org/officeDocument/2006/relationships" r:embed="rId6">
             <a:extLst>
               <a:ext uri="{28A0092B-C50C-407E-A947-70E740481C1C}">
                 <a14:useLocalDpi xmlns:a14="http://schemas.microsoft.com/office/drawing/2010/main" val="0"/>
@@ -21653,7 +21653,7 @@
           <a:p>
             <a:fld id="{C1AF180C-8747-4427-BB2D-CCDD4EE3F15C}" type="datetime1">
               <a:rPr lang="en-GB" smtClean="0"/>
-              <a:t>13/03/2026</a:t>
+              <a:t>21/04/2026</a:t>
             </a:fld>
             <a:endParaRPr lang="en-GB" dirty="0"/>
           </a:p>
@@ -21819,7 +21819,7 @@
           <a:p>
             <a:fld id="{48733B24-01F6-4E63-9EA0-1EADECE3F95E}" type="datetime1">
               <a:rPr lang="en-GB" noProof="0" smtClean="0"/>
-              <a:t>13/03/2026</a:t>
+              <a:t>21/04/2026</a:t>
             </a:fld>
             <a:endParaRPr lang="en-GB" noProof="0" dirty="0"/>
           </a:p>
@@ -22418,7 +22418,7 @@
             <a:pPr rtl="0"/>
             <a:fld id="{0368ACB3-5184-4A99-BD5F-56AB3D3ED2CB}" type="datetime1">
               <a:rPr lang="en-GB" noProof="0" smtClean="0"/>
-              <a:t>13/03/2026</a:t>
+              <a:t>21/04/2026</a:t>
             </a:fld>
             <a:endParaRPr lang="en-GB" noProof="0" dirty="0"/>
           </a:p>
@@ -22622,7 +22622,7 @@
             <a:pPr rtl="0"/>
             <a:fld id="{3B36C4A3-5B12-4119-87D0-8D39FC7D2CC7}" type="datetime1">
               <a:rPr lang="en-GB" noProof="0" smtClean="0"/>
-              <a:t>13/03/2026</a:t>
+              <a:t>21/04/2026</a:t>
             </a:fld>
             <a:endParaRPr lang="en-GB" noProof="0" dirty="0"/>
           </a:p>
@@ -23011,7 +23011,7 @@
             <a:pPr rtl="0"/>
             <a:fld id="{4EDFADDC-3910-4AC4-A7D8-E898D49EACBB}" type="datetime1">
               <a:rPr lang="en-GB" noProof="0" smtClean="0"/>
-              <a:t>13/03/2026</a:t>
+              <a:t>21/04/2026</a:t>
             </a:fld>
             <a:endParaRPr lang="en-GB" noProof="0" dirty="0"/>
           </a:p>
@@ -23282,7 +23282,7 @@
             <a:pPr rtl="0"/>
             <a:fld id="{E6A43A68-8FC1-4445-8F7E-24F318066D59}" type="datetime1">
               <a:rPr lang="en-GB" noProof="0" smtClean="0"/>
-              <a:t>13/03/2026</a:t>
+              <a:t>21/04/2026</a:t>
             </a:fld>
             <a:endParaRPr lang="en-GB" noProof="0" dirty="0"/>
           </a:p>
@@ -23695,7 +23695,7 @@
             <a:pPr rtl="0"/>
             <a:fld id="{911E46FA-4696-4713-8781-E2A911F116DE}" type="datetime1">
               <a:rPr lang="en-GB" noProof="0" smtClean="0"/>
-              <a:t>13/03/2026</a:t>
+              <a:t>21/04/2026</a:t>
             </a:fld>
             <a:endParaRPr lang="en-GB" noProof="0" dirty="0"/>
           </a:p>
@@ -23847,7 +23847,7 @@
             <a:pPr rtl="0"/>
             <a:fld id="{7C5DE13F-0970-4502-808B-8CB987AE3F63}" type="datetime1">
               <a:rPr lang="en-GB" noProof="0" smtClean="0"/>
-              <a:t>13/03/2026</a:t>
+              <a:t>21/04/2026</a:t>
             </a:fld>
             <a:endParaRPr lang="en-GB" noProof="0" dirty="0"/>
           </a:p>
@@ -24019,7 +24019,7 @@
             <a:pPr rtl="0"/>
             <a:fld id="{55606A57-68D4-474F-B9B9-5693AEFA2B02}" type="datetime1">
               <a:rPr lang="en-GB" noProof="0" smtClean="0"/>
-              <a:t>13/03/2026</a:t>
+              <a:t>21/04/2026</a:t>
             </a:fld>
             <a:endParaRPr lang="en-GB" noProof="0" dirty="0"/>
           </a:p>
@@ -24364,7 +24364,7 @@
             <a:pPr rtl="0"/>
             <a:fld id="{A5E309D9-8F57-4FD2-8AD3-41D0AF2176EB}" type="datetime1">
               <a:rPr lang="en-GB" noProof="0" smtClean="0"/>
-              <a:t>13/03/2026</a:t>
+              <a:t>21/04/2026</a:t>
             </a:fld>
             <a:endParaRPr lang="en-GB" noProof="0" dirty="0"/>
           </a:p>
@@ -24731,7 +24731,7 @@
             <a:pPr rtl="0"/>
             <a:fld id="{99D67A34-FC9B-417F-A63B-AF7A464D2285}" type="datetime1">
               <a:rPr lang="en-GB" noProof="0" smtClean="0"/>
-              <a:t>13/03/2026</a:t>
+              <a:t>21/04/2026</a:t>
             </a:fld>
             <a:endParaRPr lang="en-GB" noProof="0" dirty="0"/>
           </a:p>
@@ -25006,7 +25006,7 @@
             <a:pPr rtl="0"/>
             <a:fld id="{D1946942-6409-4E4C-8755-EBA7E31F89FB}" type="datetime1">
               <a:rPr lang="en-GB" noProof="0" smtClean="0"/>
-              <a:t>13/03/2026</a:t>
+              <a:t>21/04/2026</a:t>
             </a:fld>
             <a:endParaRPr lang="en-GB" noProof="0" dirty="0"/>
           </a:p>
@@ -25553,7 +25553,7 @@
         </p:nvSpPr>
         <p:spPr>
           <a:xfrm>
-            <a:off x="1435510" y="-540773"/>
+            <a:off x="1479691" y="-483588"/>
             <a:ext cx="9232617" cy="2750564"/>
           </a:xfrm>
         </p:spPr>
@@ -25820,7 +25820,7 @@
             </a:pPr>
             <a:r>
               <a:rPr lang="en-IN" sz="2000" dirty="0"/>
-              <a:t>1. Vipul Vijay (24204031244)					 Professor Dr. Amit Bhagat                                                                          </a:t>
+              <a:t>1. Vipul Vijay (24204031244)					                       Dr. Amit Bhagat                                                                          </a:t>
             </a:r>
           </a:p>
           <a:p>
@@ -26151,27 +26151,7 @@
                 <a:latin typeface="Times New Roman" panose="02020603050405020304" pitchFamily="18" charset="0"/>
                 <a:cs typeface="Times New Roman" panose="02020603050405020304" pitchFamily="18" charset="0"/>
               </a:rPr>
-              <a:t>Improved Retrieval Quality : </a:t>
-            </a:r>
-          </a:p>
-          <a:p>
-            <a:pPr lvl="5">
-              <a:buFont typeface="Wingdings" panose="05000000000000000000" pitchFamily="2" charset="2"/>
-              <a:buChar char="v"/>
-            </a:pPr>
-            <a:r>
-              <a:rPr lang="en-US" sz="2000" dirty="0">
-                <a:effectLst>
-                  <a:outerShdw blurRad="38100" dist="38100" dir="2700000" algn="tl">
-                    <a:srgbClr val="000000">
-                      <a:alpha val="43137"/>
-                    </a:srgbClr>
-                  </a:outerShdw>
-                </a:effectLst>
-                <a:latin typeface="Times New Roman" panose="02020603050405020304" pitchFamily="18" charset="0"/>
-                <a:cs typeface="Times New Roman" panose="02020603050405020304" pitchFamily="18" charset="0"/>
-              </a:rPr>
-              <a:t> Implement Hybrid Search (vector + Keyword search)</a:t>
+              <a:t>Improved Retrieval Quality :</a:t>
             </a:r>
           </a:p>
           <a:p>
@@ -26192,6 +26172,26 @@
                 <a:cs typeface="Times New Roman" panose="02020603050405020304" pitchFamily="18" charset="0"/>
               </a:rPr>
               <a:t>Improve chunking strategy for better context retrieval</a:t>
+            </a:r>
+          </a:p>
+          <a:p>
+            <a:pPr lvl="2">
+              <a:buFont typeface="Wingdings" panose="05000000000000000000" pitchFamily="2" charset="2"/>
+              <a:buChar char="v"/>
+            </a:pPr>
+            <a:r>
+              <a:rPr lang="en-US" sz="2000" dirty="0">
+                <a:effectLst>
+                  <a:outerShdw blurRad="38100" dist="38100" dir="2700000" algn="tl">
+                    <a:srgbClr val="000000">
+                      <a:alpha val="43137"/>
+                    </a:srgbClr>
+                  </a:outerShdw>
+                </a:effectLst>
+                <a:latin typeface="Times New Roman" panose="02020603050405020304" pitchFamily="18" charset="0"/>
+                <a:cs typeface="Times New Roman" panose="02020603050405020304" pitchFamily="18" charset="0"/>
+              </a:rPr>
+              <a:t>Implement Hybrid Search (vector + Keyword search)</a:t>
             </a:r>
           </a:p>
           <a:p>
@@ -26585,6 +26585,330 @@
           </a:p>
         </p:txBody>
       </p:sp>
+      <p:pic>
+        <p:nvPicPr>
+          <p:cNvPr id="5" name="Graphic 4" descr="Checkmark with solid fill">
+            <a:extLst>
+              <a:ext uri="{FF2B5EF4-FFF2-40B4-BE49-F238E27FC236}">
+                <a16:creationId xmlns:a16="http://schemas.microsoft.com/office/drawing/2014/main" id="{2D927176-4082-CCF9-63D7-2D5B63D48907}"/>
+              </a:ext>
+            </a:extLst>
+          </p:cNvPr>
+          <p:cNvPicPr>
+            <a:picLocks noChangeAspect="1"/>
+          </p:cNvPicPr>
+          <p:nvPr/>
+        </p:nvPicPr>
+        <p:blipFill>
+          <a:blip>
+            <a:extLst>
+              <a:ext uri="{96DAC541-7B7A-43D3-8B79-37D633B846F1}">
+                <asvg:svgBlip xmlns:asvg="http://schemas.microsoft.com/office/drawing/2016/SVG/main" r:embed="rId2"/>
+              </a:ext>
+            </a:extLst>
+          </a:blip>
+          <a:stretch>
+            <a:fillRect/>
+          </a:stretch>
+        </p:blipFill>
+        <p:spPr>
+          <a:xfrm>
+            <a:off x="4586748" y="2116393"/>
+            <a:ext cx="331839" cy="331839"/>
+          </a:xfrm>
+          <a:prstGeom prst="rect">
+            <a:avLst/>
+          </a:prstGeom>
+        </p:spPr>
+      </p:pic>
+      <p:pic>
+        <p:nvPicPr>
+          <p:cNvPr id="6" name="Graphic 5" descr="Checkmark with solid fill">
+            <a:extLst>
+              <a:ext uri="{FF2B5EF4-FFF2-40B4-BE49-F238E27FC236}">
+                <a16:creationId xmlns:a16="http://schemas.microsoft.com/office/drawing/2014/main" id="{E9B81250-6A38-08F5-69F9-3B5F462F9316}"/>
+              </a:ext>
+            </a:extLst>
+          </p:cNvPr>
+          <p:cNvPicPr>
+            <a:picLocks noChangeAspect="1"/>
+          </p:cNvPicPr>
+          <p:nvPr/>
+        </p:nvPicPr>
+        <p:blipFill>
+          <a:blip>
+            <a:extLst>
+              <a:ext uri="{96DAC541-7B7A-43D3-8B79-37D633B846F1}">
+                <asvg:svgBlip xmlns:asvg="http://schemas.microsoft.com/office/drawing/2016/SVG/main" r:embed="rId2"/>
+              </a:ext>
+            </a:extLst>
+          </a:blip>
+          <a:stretch>
+            <a:fillRect/>
+          </a:stretch>
+        </p:blipFill>
+        <p:spPr>
+          <a:xfrm>
+            <a:off x="4615015" y="2369162"/>
+            <a:ext cx="331839" cy="331839"/>
+          </a:xfrm>
+          <a:prstGeom prst="rect">
+            <a:avLst/>
+          </a:prstGeom>
+        </p:spPr>
+      </p:pic>
+      <p:pic>
+        <p:nvPicPr>
+          <p:cNvPr id="7" name="Graphic 6" descr="Checkmark with solid fill">
+            <a:extLst>
+              <a:ext uri="{FF2B5EF4-FFF2-40B4-BE49-F238E27FC236}">
+                <a16:creationId xmlns:a16="http://schemas.microsoft.com/office/drawing/2014/main" id="{1E81A62B-FB8A-A834-4AAD-9B782B1ABBD8}"/>
+              </a:ext>
+            </a:extLst>
+          </p:cNvPr>
+          <p:cNvPicPr>
+            <a:picLocks noChangeAspect="1"/>
+          </p:cNvPicPr>
+          <p:nvPr/>
+        </p:nvPicPr>
+        <p:blipFill>
+          <a:blip>
+            <a:extLst>
+              <a:ext uri="{96DAC541-7B7A-43D3-8B79-37D633B846F1}">
+                <asvg:svgBlip xmlns:asvg="http://schemas.microsoft.com/office/drawing/2016/SVG/main" r:embed="rId2"/>
+              </a:ext>
+            </a:extLst>
+          </a:blip>
+          <a:stretch>
+            <a:fillRect/>
+          </a:stretch>
+        </p:blipFill>
+        <p:spPr>
+          <a:xfrm>
+            <a:off x="3333135" y="2819399"/>
+            <a:ext cx="331839" cy="331839"/>
+          </a:xfrm>
+          <a:prstGeom prst="rect">
+            <a:avLst/>
+          </a:prstGeom>
+        </p:spPr>
+      </p:pic>
+      <p:pic>
+        <p:nvPicPr>
+          <p:cNvPr id="8" name="Graphic 7" descr="Checkmark with solid fill">
+            <a:extLst>
+              <a:ext uri="{FF2B5EF4-FFF2-40B4-BE49-F238E27FC236}">
+                <a16:creationId xmlns:a16="http://schemas.microsoft.com/office/drawing/2014/main" id="{0E752806-BCFE-1318-95B8-996115EEE034}"/>
+              </a:ext>
+            </a:extLst>
+          </p:cNvPr>
+          <p:cNvPicPr>
+            <a:picLocks noChangeAspect="1"/>
+          </p:cNvPicPr>
+          <p:nvPr/>
+        </p:nvPicPr>
+        <p:blipFill>
+          <a:blip>
+            <a:extLst>
+              <a:ext uri="{96DAC541-7B7A-43D3-8B79-37D633B846F1}">
+                <asvg:svgBlip xmlns:asvg="http://schemas.microsoft.com/office/drawing/2016/SVG/main" r:embed="rId2"/>
+              </a:ext>
+            </a:extLst>
+          </a:blip>
+          <a:stretch>
+            <a:fillRect/>
+          </a:stretch>
+        </p:blipFill>
+        <p:spPr>
+          <a:xfrm>
+            <a:off x="3499054" y="3540843"/>
+            <a:ext cx="331839" cy="331839"/>
+          </a:xfrm>
+          <a:prstGeom prst="rect">
+            <a:avLst/>
+          </a:prstGeom>
+        </p:spPr>
+      </p:pic>
+      <p:pic>
+        <p:nvPicPr>
+          <p:cNvPr id="9" name="Graphic 8" descr="Checkmark with solid fill">
+            <a:extLst>
+              <a:ext uri="{FF2B5EF4-FFF2-40B4-BE49-F238E27FC236}">
+                <a16:creationId xmlns:a16="http://schemas.microsoft.com/office/drawing/2014/main" id="{2C7A2E2E-AB83-1256-3292-9890E4961D63}"/>
+              </a:ext>
+            </a:extLst>
+          </p:cNvPr>
+          <p:cNvPicPr>
+            <a:picLocks noChangeAspect="1"/>
+          </p:cNvPicPr>
+          <p:nvPr/>
+        </p:nvPicPr>
+        <p:blipFill>
+          <a:blip>
+            <a:extLst>
+              <a:ext uri="{96DAC541-7B7A-43D3-8B79-37D633B846F1}">
+                <asvg:svgBlip xmlns:asvg="http://schemas.microsoft.com/office/drawing/2016/SVG/main" r:embed="rId2"/>
+              </a:ext>
+            </a:extLst>
+          </a:blip>
+          <a:stretch>
+            <a:fillRect/>
+          </a:stretch>
+        </p:blipFill>
+        <p:spPr>
+          <a:xfrm>
+            <a:off x="4109884" y="3770671"/>
+            <a:ext cx="331839" cy="331839"/>
+          </a:xfrm>
+          <a:prstGeom prst="rect">
+            <a:avLst/>
+          </a:prstGeom>
+        </p:spPr>
+      </p:pic>
+      <p:pic>
+        <p:nvPicPr>
+          <p:cNvPr id="10" name="Graphic 9" descr="Checkmark with solid fill">
+            <a:extLst>
+              <a:ext uri="{FF2B5EF4-FFF2-40B4-BE49-F238E27FC236}">
+                <a16:creationId xmlns:a16="http://schemas.microsoft.com/office/drawing/2014/main" id="{37B2A588-5752-3E1C-03A0-739525F01091}"/>
+              </a:ext>
+            </a:extLst>
+          </p:cNvPr>
+          <p:cNvPicPr>
+            <a:picLocks noChangeAspect="1"/>
+          </p:cNvPicPr>
+          <p:nvPr/>
+        </p:nvPicPr>
+        <p:blipFill>
+          <a:blip>
+            <a:extLst>
+              <a:ext uri="{96DAC541-7B7A-43D3-8B79-37D633B846F1}">
+                <asvg:svgBlip xmlns:asvg="http://schemas.microsoft.com/office/drawing/2016/SVG/main" r:embed="rId2"/>
+              </a:ext>
+            </a:extLst>
+          </a:blip>
+          <a:stretch>
+            <a:fillRect/>
+          </a:stretch>
+        </p:blipFill>
+        <p:spPr>
+          <a:xfrm>
+            <a:off x="3588774" y="4926576"/>
+            <a:ext cx="331839" cy="331839"/>
+          </a:xfrm>
+          <a:prstGeom prst="rect">
+            <a:avLst/>
+          </a:prstGeom>
+        </p:spPr>
+      </p:pic>
+      <p:pic>
+        <p:nvPicPr>
+          <p:cNvPr id="11" name="Graphic 10" descr="Checkmark with solid fill">
+            <a:extLst>
+              <a:ext uri="{FF2B5EF4-FFF2-40B4-BE49-F238E27FC236}">
+                <a16:creationId xmlns:a16="http://schemas.microsoft.com/office/drawing/2014/main" id="{3BA17EEE-2041-A244-D5A5-170ECC7381C9}"/>
+              </a:ext>
+            </a:extLst>
+          </p:cNvPr>
+          <p:cNvPicPr>
+            <a:picLocks noChangeAspect="1"/>
+          </p:cNvPicPr>
+          <p:nvPr/>
+        </p:nvPicPr>
+        <p:blipFill>
+          <a:blip>
+            <a:extLst>
+              <a:ext uri="{96DAC541-7B7A-43D3-8B79-37D633B846F1}">
+                <asvg:svgBlip xmlns:asvg="http://schemas.microsoft.com/office/drawing/2016/SVG/main" r:embed="rId2"/>
+              </a:ext>
+            </a:extLst>
+          </a:blip>
+          <a:stretch>
+            <a:fillRect/>
+          </a:stretch>
+        </p:blipFill>
+        <p:spPr>
+          <a:xfrm>
+            <a:off x="3580170" y="5218062"/>
+            <a:ext cx="331839" cy="331839"/>
+          </a:xfrm>
+          <a:prstGeom prst="rect">
+            <a:avLst/>
+          </a:prstGeom>
+        </p:spPr>
+      </p:pic>
+      <p:pic>
+        <p:nvPicPr>
+          <p:cNvPr id="12" name="Graphic 11" descr="Checkmark with solid fill">
+            <a:extLst>
+              <a:ext uri="{FF2B5EF4-FFF2-40B4-BE49-F238E27FC236}">
+                <a16:creationId xmlns:a16="http://schemas.microsoft.com/office/drawing/2014/main" id="{9F104697-F47B-9879-129B-3D73ED5C6506}"/>
+              </a:ext>
+            </a:extLst>
+          </p:cNvPr>
+          <p:cNvPicPr>
+            <a:picLocks noChangeAspect="1"/>
+          </p:cNvPicPr>
+          <p:nvPr/>
+        </p:nvPicPr>
+        <p:blipFill>
+          <a:blip>
+            <a:extLst>
+              <a:ext uri="{96DAC541-7B7A-43D3-8B79-37D633B846F1}">
+                <asvg:svgBlip xmlns:asvg="http://schemas.microsoft.com/office/drawing/2016/SVG/main" r:embed="rId2"/>
+              </a:ext>
+            </a:extLst>
+          </a:blip>
+          <a:stretch>
+            <a:fillRect/>
+          </a:stretch>
+        </p:blipFill>
+        <p:spPr>
+          <a:xfrm>
+            <a:off x="3754693" y="5675467"/>
+            <a:ext cx="331839" cy="331839"/>
+          </a:xfrm>
+          <a:prstGeom prst="rect">
+            <a:avLst/>
+          </a:prstGeom>
+        </p:spPr>
+      </p:pic>
+      <p:pic>
+        <p:nvPicPr>
+          <p:cNvPr id="13" name="Graphic 12" descr="Checkmark with solid fill">
+            <a:extLst>
+              <a:ext uri="{FF2B5EF4-FFF2-40B4-BE49-F238E27FC236}">
+                <a16:creationId xmlns:a16="http://schemas.microsoft.com/office/drawing/2014/main" id="{6F39A816-AE67-DA33-5962-633F94CCE90B}"/>
+              </a:ext>
+            </a:extLst>
+          </p:cNvPr>
+          <p:cNvPicPr>
+            <a:picLocks noChangeAspect="1"/>
+          </p:cNvPicPr>
+          <p:nvPr/>
+        </p:nvPicPr>
+        <p:blipFill>
+          <a:blip>
+            <a:extLst>
+              <a:ext uri="{96DAC541-7B7A-43D3-8B79-37D633B846F1}">
+                <asvg:svgBlip xmlns:asvg="http://schemas.microsoft.com/office/drawing/2016/SVG/main" r:embed="rId2"/>
+              </a:ext>
+            </a:extLst>
+          </a:blip>
+          <a:stretch>
+            <a:fillRect/>
+          </a:stretch>
+        </p:blipFill>
+        <p:spPr>
+          <a:xfrm>
+            <a:off x="4109884" y="5841386"/>
+            <a:ext cx="331839" cy="331839"/>
+          </a:xfrm>
+          <a:prstGeom prst="rect">
+            <a:avLst/>
+          </a:prstGeom>
+        </p:spPr>
+      </p:pic>
     </p:spTree>
     <p:extLst>
       <p:ext uri="{BB962C8B-B14F-4D97-AF65-F5344CB8AC3E}">
@@ -27050,18 +27374,29 @@
               <a:buChar char="v"/>
             </a:pPr>
             <a:r>
-              <a:rPr lang="en-US" sz="2000" dirty="0">
-                <a:effectLst>
-                  <a:outerShdw blurRad="38100" dist="38100" dir="2700000" algn="tl">
-                    <a:srgbClr val="000000">
-                      <a:alpha val="43137"/>
-                    </a:srgbClr>
-                  </a:outerShdw>
-                </a:effectLst>
-                <a:latin typeface="Times New Roman" panose="02020603050405020304" pitchFamily="18" charset="0"/>
-                <a:cs typeface="Times New Roman" panose="02020603050405020304" pitchFamily="18" charset="0"/>
-              </a:rPr>
-              <a:t>Educational lectures on YouTube are often very long</a:t>
+              <a:rPr lang="en-US" sz="2000" dirty="0"/>
+              <a:t>Educational lectures on platforms like YouTube are often long and unstructured</a:t>
+            </a:r>
+            <a:endParaRPr lang="en-US" sz="2000" dirty="0">
+              <a:effectLst>
+                <a:outerShdw blurRad="38100" dist="38100" dir="2700000" algn="tl">
+                  <a:srgbClr val="000000">
+                    <a:alpha val="43137"/>
+                  </a:srgbClr>
+                </a:outerShdw>
+              </a:effectLst>
+              <a:latin typeface="Times New Roman" panose="02020603050405020304" pitchFamily="18" charset="0"/>
+              <a:cs typeface="Times New Roman" panose="02020603050405020304" pitchFamily="18" charset="0"/>
+            </a:endParaRPr>
+          </a:p>
+          <a:p>
+            <a:pPr>
+              <a:buFont typeface="Wingdings" panose="05000000000000000000" pitchFamily="2" charset="2"/>
+              <a:buChar char="v"/>
+            </a:pPr>
+            <a:r>
+              <a:rPr lang="en-US" sz="2000" dirty="0"/>
+              <a:t>Locating specific concepts or explanations requires manual scrubbing through the video timeline</a:t>
             </a:r>
           </a:p>
           <a:p>
@@ -27070,18 +27405,8 @@
               <a:buChar char="v"/>
             </a:pPr>
             <a:r>
-              <a:rPr lang="en-US" sz="2000" dirty="0">
-                <a:effectLst>
-                  <a:outerShdw blurRad="38100" dist="38100" dir="2700000" algn="tl">
-                    <a:srgbClr val="000000">
-                      <a:alpha val="43137"/>
-                    </a:srgbClr>
-                  </a:outerShdw>
-                </a:effectLst>
-                <a:latin typeface="Times New Roman" panose="02020603050405020304" pitchFamily="18" charset="0"/>
-                <a:cs typeface="Times New Roman" panose="02020603050405020304" pitchFamily="18" charset="0"/>
-              </a:rPr>
-              <a:t>Finding specific explanations is difficult</a:t>
+              <a:rPr lang="en-US" sz="2000" dirty="0"/>
+              <a:t>Traditional search is limited to titles/descriptions, not the actual lecture content</a:t>
             </a:r>
           </a:p>
           <a:p>
@@ -27090,18 +27415,16 @@
               <a:buChar char="v"/>
             </a:pPr>
             <a:r>
-              <a:rPr lang="en-US" sz="2000" dirty="0">
-                <a:effectLst>
-                  <a:outerShdw blurRad="38100" dist="38100" dir="2700000" algn="tl">
-                    <a:srgbClr val="000000">
-                      <a:alpha val="43137"/>
-                    </a:srgbClr>
-                  </a:outerShdw>
-                </a:effectLst>
-                <a:latin typeface="Times New Roman" panose="02020603050405020304" pitchFamily="18" charset="0"/>
-                <a:cs typeface="Times New Roman" panose="02020603050405020304" pitchFamily="18" charset="0"/>
-              </a:rPr>
-              <a:t>Students must manually navigate through videos</a:t>
+              <a:rPr lang="en-US" sz="2000" dirty="0"/>
+              <a:t>Lack of </a:t>
+            </a:r>
+            <a:r>
+              <a:rPr lang="en-US" sz="2000" b="1" dirty="0"/>
+              <a:t>semantic understanding</a:t>
+            </a:r>
+            <a:r>
+              <a:rPr lang="en-US" sz="2000" dirty="0"/>
+              <a:t> makes it difficult to ask natural language questions</a:t>
             </a:r>
           </a:p>
           <a:p>
@@ -27110,19 +27433,25 @@
               <a:buChar char="v"/>
             </a:pPr>
             <a:r>
-              <a:rPr lang="en-US" sz="2000" dirty="0">
-                <a:effectLst>
-                  <a:outerShdw blurRad="38100" dist="38100" dir="2700000" algn="tl">
-                    <a:srgbClr val="000000">
-                      <a:alpha val="43137"/>
-                    </a:srgbClr>
-                  </a:outerShdw>
-                </a:effectLst>
-                <a:latin typeface="Times New Roman" panose="02020603050405020304" pitchFamily="18" charset="0"/>
-                <a:cs typeface="Times New Roman" panose="02020603050405020304" pitchFamily="18" charset="0"/>
-              </a:rPr>
-              <a:t>Lack of semantic search within lecture content</a:t>
+              <a:rPr lang="en-US" sz="2000" dirty="0"/>
+              <a:t>No direct way to jump to the exact timestamp where a concept is explained </a:t>
             </a:r>
+          </a:p>
+          <a:p>
+            <a:pPr marL="0" indent="0">
+              <a:buNone/>
+            </a:pPr>
+            <a:endParaRPr lang="en-US" sz="2000" dirty="0">
+              <a:effectLst>
+                <a:outerShdw blurRad="38100" dist="38100" dir="2700000" algn="tl">
+                  <a:srgbClr val="000000">
+                    <a:alpha val="43137"/>
+                  </a:srgbClr>
+                </a:outerShdw>
+              </a:effectLst>
+              <a:latin typeface="Times New Roman" panose="02020603050405020304" pitchFamily="18" charset="0"/>
+              <a:cs typeface="Times New Roman" panose="02020603050405020304" pitchFamily="18" charset="0"/>
+            </a:endParaRPr>
           </a:p>
         </p:txBody>
       </p:sp>
@@ -27237,16 +27566,27 @@
               <a:buChar char="v"/>
             </a:pPr>
             <a:r>
-              <a:rPr lang="en-US" sz="2000" dirty="0">
-                <a:effectLst>
-                  <a:outerShdw blurRad="38100" dist="38100" dir="2700000" algn="tl">
-                    <a:srgbClr val="000000">
-                      <a:alpha val="43137"/>
-                    </a:srgbClr>
-                  </a:outerShdw>
-                </a:effectLst>
-              </a:rPr>
-              <a:t>Online learning is growing rapidly</a:t>
+              <a:rPr lang="en-US" sz="2000" dirty="0"/>
+              <a:t>Rapid growth of online learning platforms like YouTube has increased dependence on video-based education</a:t>
+            </a:r>
+            <a:endParaRPr lang="en-US" sz="2000" dirty="0">
+              <a:effectLst>
+                <a:outerShdw blurRad="38100" dist="38100" dir="2700000" algn="tl">
+                  <a:srgbClr val="000000">
+                    <a:alpha val="43137"/>
+                  </a:srgbClr>
+                </a:outerShdw>
+              </a:effectLst>
+            </a:endParaRPr>
+          </a:p>
+          <a:p>
+            <a:pPr>
+              <a:buFont typeface="Wingdings" panose="05000000000000000000" pitchFamily="2" charset="2"/>
+              <a:buChar char="v"/>
+            </a:pPr>
+            <a:r>
+              <a:rPr lang="en-US" sz="2000" dirty="0"/>
+              <a:t>Students spend significant time searching for specific concepts within lengthy lectures</a:t>
             </a:r>
           </a:p>
           <a:p>
@@ -27255,16 +27595,16 @@
               <a:buChar char="v"/>
             </a:pPr>
             <a:r>
-              <a:rPr lang="en-US" sz="2000" dirty="0">
-                <a:effectLst>
-                  <a:outerShdw blurRad="38100" dist="38100" dir="2700000" algn="tl">
-                    <a:srgbClr val="000000">
-                      <a:alpha val="43137"/>
-                    </a:srgbClr>
-                  </a:outerShdw>
-                </a:effectLst>
-              </a:rPr>
-              <a:t>Efficient knowledge retrieval is important</a:t>
+              <a:rPr lang="en-US" sz="2000" dirty="0"/>
+              <a:t>Students also require </a:t>
+            </a:r>
+            <a:r>
+              <a:rPr lang="en-US" sz="2000" b="1" dirty="0"/>
+              <a:t>concise learning aids</a:t>
+            </a:r>
+            <a:r>
+              <a:rPr lang="en-US" sz="2000" dirty="0"/>
+              <a:t> such as notes and flashcards for effective revision</a:t>
             </a:r>
           </a:p>
           <a:p>
@@ -27273,17 +27613,24 @@
               <a:buChar char="v"/>
             </a:pPr>
             <a:r>
-              <a:rPr lang="en-US" sz="2000" dirty="0">
-                <a:effectLst>
-                  <a:outerShdw blurRad="38100" dist="38100" dir="2700000" algn="tl">
-                    <a:srgbClr val="000000">
-                      <a:alpha val="43137"/>
-                    </a:srgbClr>
-                  </a:outerShdw>
-                </a:effectLst>
-              </a:rPr>
-              <a:t>Efficient knowledge retrieval is important</a:t>
+              <a:rPr lang="en-US" sz="2000" dirty="0"/>
+              <a:t>Enhancing learning efficiency can significantly improve student productivity and experience </a:t>
             </a:r>
+          </a:p>
+          <a:p>
+            <a:pPr>
+              <a:buFont typeface="Wingdings" panose="05000000000000000000" pitchFamily="2" charset="2"/>
+              <a:buChar char="v"/>
+            </a:pPr>
+            <a:endParaRPr lang="en-US" sz="2000" dirty="0">
+              <a:effectLst>
+                <a:outerShdw blurRad="38100" dist="38100" dir="2700000" algn="tl">
+                  <a:srgbClr val="000000">
+                    <a:alpha val="43137"/>
+                  </a:srgbClr>
+                </a:outerShdw>
+              </a:effectLst>
+            </a:endParaRPr>
           </a:p>
         </p:txBody>
       </p:sp>
@@ -27433,8 +27780,21 @@
                   </a:outerShdw>
                 </a:effectLst>
               </a:rPr>
-              <a:t> Ask question about the lecture</a:t>
+              <a:t> </a:t>
             </a:r>
+            <a:r>
+              <a:rPr lang="en-US" sz="2000" dirty="0"/>
+              <a:t>Ask natural language questions about the lecture</a:t>
+            </a:r>
+            <a:endParaRPr lang="en-US" sz="2000" dirty="0">
+              <a:effectLst>
+                <a:outerShdw blurRad="38100" dist="38100" dir="2700000" algn="tl">
+                  <a:srgbClr val="000000">
+                    <a:alpha val="43137"/>
+                  </a:srgbClr>
+                </a:outerShdw>
+              </a:effectLst>
+            </a:endParaRPr>
           </a:p>
           <a:p>
             <a:pPr>
@@ -27451,8 +27811,21 @@
                   </a:outerShdw>
                 </a:effectLst>
               </a:rPr>
-              <a:t> Retrieve relevant transcript segments</a:t>
+              <a:t> </a:t>
             </a:r>
+            <a:r>
+              <a:rPr lang="en-US" sz="2000" dirty="0"/>
+              <a:t>Generate accurate answers using AI-powered models</a:t>
+            </a:r>
+            <a:endParaRPr lang="en-US" sz="2000" dirty="0">
+              <a:effectLst>
+                <a:outerShdw blurRad="38100" dist="38100" dir="2700000" algn="tl">
+                  <a:srgbClr val="000000">
+                    <a:alpha val="43137"/>
+                  </a:srgbClr>
+                </a:outerShdw>
+              </a:effectLst>
+            </a:endParaRPr>
           </a:p>
           <a:p>
             <a:pPr>
@@ -27469,7 +27842,11 @@
                   </a:outerShdw>
                 </a:effectLst>
               </a:rPr>
-              <a:t> Generate answer using AI</a:t>
+              <a:t> </a:t>
+            </a:r>
+            <a:r>
+              <a:rPr lang="en-US" sz="2000" dirty="0"/>
+              <a:t>Jump directly to the exact timestamp where the concept is explained</a:t>
             </a:r>
           </a:p>
           <a:p>
@@ -27478,17 +27855,44 @@
               <a:buChar char="v"/>
             </a:pPr>
             <a:r>
-              <a:rPr lang="en-US" sz="2000" dirty="0">
-                <a:effectLst>
-                  <a:outerShdw blurRad="38100" dist="38100" dir="2700000" algn="tl">
-                    <a:srgbClr val="000000">
-                      <a:alpha val="43137"/>
-                    </a:srgbClr>
-                  </a:outerShdw>
-                </a:effectLst>
-              </a:rPr>
-              <a:t> Jump directly to relevant timestamp</a:t>
+              <a:rPr lang="en-US" sz="2000" dirty="0"/>
+              <a:t>Automatically generate </a:t>
             </a:r>
+            <a:r>
+              <a:rPr lang="en-US" sz="2000" b="1" dirty="0"/>
+              <a:t>concise notes</a:t>
+            </a:r>
+            <a:r>
+              <a:rPr lang="en-US" sz="2000" dirty="0"/>
+              <a:t> for quick understanding</a:t>
+            </a:r>
+          </a:p>
+          <a:p>
+            <a:pPr>
+              <a:buFont typeface="Wingdings" panose="05000000000000000000" pitchFamily="2" charset="2"/>
+              <a:buChar char="v"/>
+            </a:pPr>
+            <a:r>
+              <a:rPr lang="en-US" sz="2000" dirty="0"/>
+              <a:t>Create </a:t>
+            </a:r>
+            <a:r>
+              <a:rPr lang="en-US" sz="2000" b="1" dirty="0"/>
+              <a:t>flashcards</a:t>
+            </a:r>
+            <a:r>
+              <a:rPr lang="en-US" sz="2000" dirty="0"/>
+              <a:t> for efficient revision and memory retention</a:t>
+            </a:r>
+            <a:endParaRPr lang="en-US" sz="2000" dirty="0">
+              <a:effectLst>
+                <a:outerShdw blurRad="38100" dist="38100" dir="2700000" algn="tl">
+                  <a:srgbClr val="000000">
+                    <a:alpha val="43137"/>
+                  </a:srgbClr>
+                </a:outerShdw>
+              </a:effectLst>
+            </a:endParaRPr>
           </a:p>
           <a:p>
             <a:pPr>

</xml_diff>